<commit_message>
update script + diapo avec le bon nombre de variables
</commit_message>
<xml_diff>
--- a/update_relation_new_blocks.pptx
+++ b/update_relation_new_blocks.pptx
@@ -259,7 +259,7 @@
           <a:p>
             <a:fld id="{490C79C5-3CC8-4373-907F-2E1F47B9C95B}" type="datetimeFigureOut">
               <a:rPr lang="fr-FR" smtClean="0"/>
-              <a:t>29/05/2026</a:t>
+              <a:t>29/06/2026</a:t>
             </a:fld>
             <a:endParaRPr lang="fr-FR"/>
           </a:p>
@@ -457,7 +457,7 @@
           <a:p>
             <a:fld id="{490C79C5-3CC8-4373-907F-2E1F47B9C95B}" type="datetimeFigureOut">
               <a:rPr lang="fr-FR" smtClean="0"/>
-              <a:t>29/05/2026</a:t>
+              <a:t>29/06/2026</a:t>
             </a:fld>
             <a:endParaRPr lang="fr-FR"/>
           </a:p>
@@ -665,7 +665,7 @@
           <a:p>
             <a:fld id="{490C79C5-3CC8-4373-907F-2E1F47B9C95B}" type="datetimeFigureOut">
               <a:rPr lang="fr-FR" smtClean="0"/>
-              <a:t>29/05/2026</a:t>
+              <a:t>29/06/2026</a:t>
             </a:fld>
             <a:endParaRPr lang="fr-FR"/>
           </a:p>
@@ -863,7 +863,7 @@
           <a:p>
             <a:fld id="{490C79C5-3CC8-4373-907F-2E1F47B9C95B}" type="datetimeFigureOut">
               <a:rPr lang="fr-FR" smtClean="0"/>
-              <a:t>29/05/2026</a:t>
+              <a:t>29/06/2026</a:t>
             </a:fld>
             <a:endParaRPr lang="fr-FR"/>
           </a:p>
@@ -1138,7 +1138,7 @@
           <a:p>
             <a:fld id="{490C79C5-3CC8-4373-907F-2E1F47B9C95B}" type="datetimeFigureOut">
               <a:rPr lang="fr-FR" smtClean="0"/>
-              <a:t>29/05/2026</a:t>
+              <a:t>29/06/2026</a:t>
             </a:fld>
             <a:endParaRPr lang="fr-FR"/>
           </a:p>
@@ -1403,7 +1403,7 @@
           <a:p>
             <a:fld id="{490C79C5-3CC8-4373-907F-2E1F47B9C95B}" type="datetimeFigureOut">
               <a:rPr lang="fr-FR" smtClean="0"/>
-              <a:t>29/05/2026</a:t>
+              <a:t>29/06/2026</a:t>
             </a:fld>
             <a:endParaRPr lang="fr-FR"/>
           </a:p>
@@ -1815,7 +1815,7 @@
           <a:p>
             <a:fld id="{490C79C5-3CC8-4373-907F-2E1F47B9C95B}" type="datetimeFigureOut">
               <a:rPr lang="fr-FR" smtClean="0"/>
-              <a:t>29/05/2026</a:t>
+              <a:t>29/06/2026</a:t>
             </a:fld>
             <a:endParaRPr lang="fr-FR"/>
           </a:p>
@@ -1956,7 +1956,7 @@
           <a:p>
             <a:fld id="{490C79C5-3CC8-4373-907F-2E1F47B9C95B}" type="datetimeFigureOut">
               <a:rPr lang="fr-FR" smtClean="0"/>
-              <a:t>29/05/2026</a:t>
+              <a:t>29/06/2026</a:t>
             </a:fld>
             <a:endParaRPr lang="fr-FR"/>
           </a:p>
@@ -2069,7 +2069,7 @@
           <a:p>
             <a:fld id="{490C79C5-3CC8-4373-907F-2E1F47B9C95B}" type="datetimeFigureOut">
               <a:rPr lang="fr-FR" smtClean="0"/>
-              <a:t>29/05/2026</a:t>
+              <a:t>29/06/2026</a:t>
             </a:fld>
             <a:endParaRPr lang="fr-FR"/>
           </a:p>
@@ -2380,7 +2380,7 @@
           <a:p>
             <a:fld id="{490C79C5-3CC8-4373-907F-2E1F47B9C95B}" type="datetimeFigureOut">
               <a:rPr lang="fr-FR" smtClean="0"/>
-              <a:t>29/05/2026</a:t>
+              <a:t>29/06/2026</a:t>
             </a:fld>
             <a:endParaRPr lang="fr-FR"/>
           </a:p>
@@ -2668,7 +2668,7 @@
           <a:p>
             <a:fld id="{490C79C5-3CC8-4373-907F-2E1F47B9C95B}" type="datetimeFigureOut">
               <a:rPr lang="fr-FR" smtClean="0"/>
-              <a:t>29/05/2026</a:t>
+              <a:t>29/06/2026</a:t>
             </a:fld>
             <a:endParaRPr lang="fr-FR"/>
           </a:p>
@@ -2909,7 +2909,7 @@
           <a:p>
             <a:fld id="{490C79C5-3CC8-4373-907F-2E1F47B9C95B}" type="datetimeFigureOut">
               <a:rPr lang="fr-FR" smtClean="0"/>
-              <a:t>29/05/2026</a:t>
+              <a:t>29/06/2026</a:t>
             </a:fld>
             <a:endParaRPr lang="fr-FR"/>
           </a:p>
@@ -3561,7 +3561,21 @@
                   <a:latin typeface="Arial" panose="020B0604020202020204" pitchFamily="34" charset="0"/>
                   <a:cs typeface="Arial" panose="020B0604020202020204" pitchFamily="34" charset="0"/>
                 </a:rPr>
-                <a:t> max 22 variables</a:t>
+                <a:t> </a:t>
+              </a:r>
+              <a:r>
+                <a:rPr lang="fr-FR" sz="900">
+                  <a:latin typeface="Arial" panose="020B0604020202020204" pitchFamily="34" charset="0"/>
+                  <a:cs typeface="Arial" panose="020B0604020202020204" pitchFamily="34" charset="0"/>
+                </a:rPr>
+                <a:t>max 3 </a:t>
+              </a:r>
+              <a:r>
+                <a:rPr lang="fr-FR" sz="900" dirty="0">
+                  <a:latin typeface="Arial" panose="020B0604020202020204" pitchFamily="34" charset="0"/>
+                  <a:cs typeface="Arial" panose="020B0604020202020204" pitchFamily="34" charset="0"/>
+                </a:rPr>
+                <a:t>variables</a:t>
               </a:r>
             </a:p>
           </p:txBody>
@@ -3802,7 +3816,7 @@
                   <a:latin typeface="Arial" panose="020B0604020202020204" pitchFamily="34" charset="0"/>
                   <a:cs typeface="Arial" panose="020B0604020202020204" pitchFamily="34" charset="0"/>
                 </a:rPr>
-                <a:t> max 28 variables</a:t>
+                <a:t> max 4 variables</a:t>
               </a:r>
             </a:p>
           </p:txBody>
@@ -4043,7 +4057,7 @@
                   <a:latin typeface="Arial" panose="020B0604020202020204" pitchFamily="34" charset="0"/>
                   <a:cs typeface="Arial" panose="020B0604020202020204" pitchFamily="34" charset="0"/>
                 </a:rPr>
-                <a:t> max 11 variables</a:t>
+                <a:t> max 2 variables</a:t>
               </a:r>
             </a:p>
           </p:txBody>
@@ -4284,7 +4298,7 @@
                   <a:latin typeface="Arial" panose="020B0604020202020204" pitchFamily="34" charset="0"/>
                   <a:cs typeface="Arial" panose="020B0604020202020204" pitchFamily="34" charset="0"/>
                 </a:rPr>
-                <a:t> max 22 variables</a:t>
+                <a:t> max 3 variables</a:t>
               </a:r>
             </a:p>
           </p:txBody>

</xml_diff>